<commit_message>
Add blue SPX tool image and use it in the SPX data sheet
Co-Authored-By: Claude Sonnet 5.5 <noreply@anthropic.com>
Claude-Session: https://claude.ai/code/session_01XPwnZBmWUGhvYebrP3X3Z2
</commit_message>
<xml_diff>
--- a/Fiche_technique_SPX.pptx
+++ b/Fiche_technique_SPX.pptx
@@ -9764,7 +9764,7 @@
       </p:sp>
       <p:pic>
         <p:nvPicPr>
-          <p:cNvPr id="32" name="Picture 31" descr="spx_tool_h.png"/>
+          <p:cNvPr id="32" name="Picture 31" descr="spx_tool_blue.png"/>
           <p:cNvPicPr>
             <a:picLocks noChangeAspect="1"/>
           </p:cNvPicPr>
@@ -9778,8 +9778,8 @@
         </p:blipFill>
         <p:spPr>
           <a:xfrm>
-            <a:off x="711200" y="9601200"/>
-            <a:ext cx="3683000" cy="670306"/>
+            <a:off x="711200" y="9626600"/>
+            <a:ext cx="3810000" cy="693874"/>
           </a:xfrm>
           <a:prstGeom prst="rect">
             <a:avLst/>

</xml_diff>